<commit_message>
Added new folder with updated project files
</commit_message>
<xml_diff>
--- a/presentation/Project Overview.pptx
+++ b/presentation/Project Overview.pptx
@@ -16,7 +16,10 @@
     <p:sldId id="264" r:id="rId10"/>
     <p:sldId id="265" r:id="rId11"/>
     <p:sldId id="266" r:id="rId12"/>
-    <p:sldId id="270" r:id="rId13"/>
+    <p:sldId id="273" r:id="rId13"/>
+    <p:sldId id="271" r:id="rId14"/>
+    <p:sldId id="272" r:id="rId15"/>
+    <p:sldId id="270" r:id="rId16"/>
   </p:sldIdLst>
   <p:sldSz cx="9144000" cy="6858000" type="screen4x3"/>
   <p:notesSz cx="6858000" cy="9144000"/>
@@ -319,7 +322,7 @@
           <a:p>
             <a:fld id="{5BCAD085-E8A6-8845-BD4E-CB4CCA059FC4}" type="datetimeFigureOut">
               <a:rPr lang="en-US" smtClean="0"/>
-              <a:t>3/31/2026</a:t>
+              <a:t>4/18/2026</a:t>
             </a:fld>
             <a:endParaRPr lang="en-US"/>
           </a:p>
@@ -617,7 +620,7 @@
           <a:p>
             <a:fld id="{5BCAD085-E8A6-8845-BD4E-CB4CCA059FC4}" type="datetimeFigureOut">
               <a:rPr lang="en-US" smtClean="0"/>
-              <a:t>3/31/2026</a:t>
+              <a:t>4/18/2026</a:t>
             </a:fld>
             <a:endParaRPr lang="en-US"/>
           </a:p>
@@ -809,7 +812,7 @@
           <a:p>
             <a:fld id="{5BCAD085-E8A6-8845-BD4E-CB4CCA059FC4}" type="datetimeFigureOut">
               <a:rPr lang="en-US" smtClean="0"/>
-              <a:t>3/31/2026</a:t>
+              <a:t>4/18/2026</a:t>
             </a:fld>
             <a:endParaRPr lang="en-US"/>
           </a:p>
@@ -1070,7 +1073,7 @@
           <a:p>
             <a:fld id="{5BCAD085-E8A6-8845-BD4E-CB4CCA059FC4}" type="datetimeFigureOut">
               <a:rPr lang="en-US" smtClean="0"/>
-              <a:t>3/31/2026</a:t>
+              <a:t>4/18/2026</a:t>
             </a:fld>
             <a:endParaRPr lang="en-US"/>
           </a:p>
@@ -1494,7 +1497,7 @@
           <a:p>
             <a:fld id="{5BCAD085-E8A6-8845-BD4E-CB4CCA059FC4}" type="datetimeFigureOut">
               <a:rPr lang="en-US" smtClean="0"/>
-              <a:t>3/31/2026</a:t>
+              <a:t>4/18/2026</a:t>
             </a:fld>
             <a:endParaRPr lang="en-US"/>
           </a:p>
@@ -2031,7 +2034,7 @@
           <a:p>
             <a:fld id="{5BCAD085-E8A6-8845-BD4E-CB4CCA059FC4}" type="datetimeFigureOut">
               <a:rPr lang="en-US" smtClean="0"/>
-              <a:t>3/31/2026</a:t>
+              <a:t>4/18/2026</a:t>
             </a:fld>
             <a:endParaRPr lang="en-US"/>
           </a:p>
@@ -2895,7 +2898,7 @@
           <a:p>
             <a:fld id="{5BCAD085-E8A6-8845-BD4E-CB4CCA059FC4}" type="datetimeFigureOut">
               <a:rPr lang="en-US" smtClean="0"/>
-              <a:t>3/31/2026</a:t>
+              <a:t>4/18/2026</a:t>
             </a:fld>
             <a:endParaRPr lang="en-US"/>
           </a:p>
@@ -3065,7 +3068,7 @@
           <a:p>
             <a:fld id="{5BCAD085-E8A6-8845-BD4E-CB4CCA059FC4}" type="datetimeFigureOut">
               <a:rPr lang="en-US" smtClean="0"/>
-              <a:t>3/31/2026</a:t>
+              <a:t>4/18/2026</a:t>
             </a:fld>
             <a:endParaRPr lang="en-US"/>
           </a:p>
@@ -3249,7 +3252,7 @@
           <a:p>
             <a:fld id="{5BCAD085-E8A6-8845-BD4E-CB4CCA059FC4}" type="datetimeFigureOut">
               <a:rPr lang="en-US" smtClean="0"/>
-              <a:t>3/31/2026</a:t>
+              <a:t>4/18/2026</a:t>
             </a:fld>
             <a:endParaRPr lang="en-US"/>
           </a:p>
@@ -3419,7 +3422,7 @@
           <a:p>
             <a:fld id="{5BCAD085-E8A6-8845-BD4E-CB4CCA059FC4}" type="datetimeFigureOut">
               <a:rPr lang="en-US" smtClean="0"/>
-              <a:t>3/31/2026</a:t>
+              <a:t>4/18/2026</a:t>
             </a:fld>
             <a:endParaRPr lang="en-US"/>
           </a:p>
@@ -3663,7 +3666,7 @@
           <a:p>
             <a:fld id="{5BCAD085-E8A6-8845-BD4E-CB4CCA059FC4}" type="datetimeFigureOut">
               <a:rPr lang="en-US" smtClean="0"/>
-              <a:t>3/31/2026</a:t>
+              <a:t>4/18/2026</a:t>
             </a:fld>
             <a:endParaRPr lang="en-US"/>
           </a:p>
@@ -3899,7 +3902,7 @@
           <a:p>
             <a:fld id="{5BCAD085-E8A6-8845-BD4E-CB4CCA059FC4}" type="datetimeFigureOut">
               <a:rPr lang="en-US" smtClean="0"/>
-              <a:t>3/31/2026</a:t>
+              <a:t>4/18/2026</a:t>
             </a:fld>
             <a:endParaRPr lang="en-US"/>
           </a:p>
@@ -4365,7 +4368,7 @@
           <a:p>
             <a:fld id="{5BCAD085-E8A6-8845-BD4E-CB4CCA059FC4}" type="datetimeFigureOut">
               <a:rPr lang="en-US" smtClean="0"/>
-              <a:t>3/31/2026</a:t>
+              <a:t>4/18/2026</a:t>
             </a:fld>
             <a:endParaRPr lang="en-US"/>
           </a:p>
@@ -4483,7 +4486,7 @@
           <a:p>
             <a:fld id="{5BCAD085-E8A6-8845-BD4E-CB4CCA059FC4}" type="datetimeFigureOut">
               <a:rPr lang="en-US" smtClean="0"/>
-              <a:t>3/31/2026</a:t>
+              <a:t>4/18/2026</a:t>
             </a:fld>
             <a:endParaRPr lang="en-US"/>
           </a:p>
@@ -4578,7 +4581,7 @@
           <a:p>
             <a:fld id="{5BCAD085-E8A6-8845-BD4E-CB4CCA059FC4}" type="datetimeFigureOut">
               <a:rPr lang="en-US" smtClean="0"/>
-              <a:t>3/31/2026</a:t>
+              <a:t>4/18/2026</a:t>
             </a:fld>
             <a:endParaRPr lang="en-US"/>
           </a:p>
@@ -4833,7 +4836,7 @@
           <a:p>
             <a:fld id="{5BCAD085-E8A6-8845-BD4E-CB4CCA059FC4}" type="datetimeFigureOut">
               <a:rPr lang="en-US" smtClean="0"/>
-              <a:t>3/31/2026</a:t>
+              <a:t>4/18/2026</a:t>
             </a:fld>
             <a:endParaRPr lang="en-US"/>
           </a:p>
@@ -5133,7 +5136,7 @@
           <a:p>
             <a:fld id="{5BCAD085-E8A6-8845-BD4E-CB4CCA059FC4}" type="datetimeFigureOut">
               <a:rPr lang="en-US" smtClean="0"/>
-              <a:t>3/31/2026</a:t>
+              <a:t>4/18/2026</a:t>
             </a:fld>
             <a:endParaRPr lang="en-US"/>
           </a:p>
@@ -5198,9 +5201,18 @@
 <p:sldMaster xmlns:a="http://schemas.openxmlformats.org/drawingml/2006/main" xmlns:r="http://schemas.openxmlformats.org/officeDocument/2006/relationships" xmlns:p="http://schemas.openxmlformats.org/presentationml/2006/main">
   <p:cSld>
     <p:bg>
-      <p:bgRef idx="1003">
-        <a:schemeClr val="bg2"/>
-      </p:bgRef>
+      <p:bgPr>
+        <a:blipFill dpi="0" rotWithShape="1">
+          <a:blip r:embed="rId19">
+            <a:lum/>
+          </a:blip>
+          <a:srcRect/>
+          <a:stretch>
+            <a:fillRect l="-22000" r="-22000"/>
+          </a:stretch>
+        </a:blipFill>
+        <a:effectLst/>
+      </p:bgPr>
     </p:bg>
     <p:spTree>
       <p:nvGrpSpPr>
@@ -5367,7 +5379,7 @@
           <a:p>
             <a:fld id="{5BCAD085-E8A6-8845-BD4E-CB4CCA059FC4}" type="datetimeFigureOut">
               <a:rPr lang="en-US" smtClean="0"/>
-              <a:t>3/31/2026</a:t>
+              <a:t>4/18/2026</a:t>
             </a:fld>
             <a:endParaRPr lang="en-US"/>
           </a:p>
@@ -6053,7 +6065,7 @@
         </p:nvSpPr>
         <p:spPr>
           <a:xfrm>
-            <a:off x="784406" y="2346960"/>
+            <a:off x="775075" y="2463526"/>
             <a:ext cx="7765322" cy="970450"/>
           </a:xfrm>
         </p:spPr>
@@ -6111,7 +6123,7 @@
         </p:nvSpPr>
         <p:spPr>
           <a:xfrm>
-            <a:off x="689339" y="264160"/>
+            <a:off x="502726" y="267063"/>
             <a:ext cx="7765322" cy="970450"/>
           </a:xfrm>
         </p:spPr>
@@ -6119,6 +6131,7 @@
           <a:bodyPr/>
           <a:lstStyle/>
           <a:p>
+            <a:pPr algn="l"/>
             <a:r>
               <a:rPr dirty="0">
                 <a:solidFill>
@@ -6764,23 +6777,60 @@
             <p:ph type="title"/>
           </p:nvPr>
         </p:nvSpPr>
-        <p:spPr/>
+        <p:spPr>
+          <a:xfrm>
+            <a:off x="689339" y="2452330"/>
+            <a:ext cx="7765322" cy="970450"/>
+          </a:xfrm>
+        </p:spPr>
         <p:txBody>
           <a:bodyPr/>
           <a:lstStyle/>
           <a:p>
             <a:r>
+              <a:rPr dirty="0"/>
               <a:t>Dashboard Overview</a:t>
             </a:r>
           </a:p>
         </p:txBody>
       </p:sp>
+    </p:spTree>
+  </p:cSld>
+  <p:clrMapOvr>
+    <a:masterClrMapping/>
+  </p:clrMapOvr>
+</p:sld>
+</file>
+
+<file path=ppt/slides/slide12.xml><?xml version="1.0" encoding="utf-8"?>
+<p:sld xmlns:a="http://schemas.openxmlformats.org/drawingml/2006/main" xmlns:r="http://schemas.openxmlformats.org/officeDocument/2006/relationships" xmlns:p="http://schemas.openxmlformats.org/presentationml/2006/main">
+  <p:cSld>
+    <p:spTree>
+      <p:nvGrpSpPr>
+        <p:cNvPr id="1" name="">
+          <a:extLst>
+            <a:ext uri="{FF2B5EF4-FFF2-40B4-BE49-F238E27FC236}">
+              <a16:creationId xmlns:a16="http://schemas.microsoft.com/office/drawing/2014/main" id="{D5FBBE74-7B79-483C-D913-0A8586ADD695}"/>
+            </a:ext>
+          </a:extLst>
+        </p:cNvPr>
+        <p:cNvGrpSpPr/>
+        <p:nvPr/>
+      </p:nvGrpSpPr>
+      <p:grpSpPr>
+        <a:xfrm>
+          <a:off x="0" y="0"/>
+          <a:ext cx="0" cy="0"/>
+          <a:chOff x="0" y="0"/>
+          <a:chExt cx="0" cy="0"/>
+        </a:xfrm>
+      </p:grpSpPr>
       <p:pic>
         <p:nvPicPr>
-          <p:cNvPr id="5" name="Picture 4">
+          <p:cNvPr id="7" name="Picture 6">
             <a:extLst>
               <a:ext uri="{FF2B5EF4-FFF2-40B4-BE49-F238E27FC236}">
-                <a16:creationId xmlns:a16="http://schemas.microsoft.com/office/drawing/2014/main" id="{29CB5405-911D-69CA-85F1-8BFDF9E316DD}"/>
+                <a16:creationId xmlns:a16="http://schemas.microsoft.com/office/drawing/2014/main" id="{C06AEA48-642B-C50E-8A0B-5C6AED03C2C3}"/>
               </a:ext>
             </a:extLst>
           </p:cNvPr>
@@ -6797,20 +6847,56 @@
         </p:blipFill>
         <p:spPr>
           <a:xfrm>
-            <a:off x="509276" y="1472867"/>
-            <a:ext cx="3696514" cy="2335094"/>
+            <a:off x="0" y="550865"/>
+            <a:ext cx="9144000" cy="5756270"/>
           </a:xfrm>
           <a:prstGeom prst="rect">
             <a:avLst/>
           </a:prstGeom>
         </p:spPr>
       </p:pic>
+    </p:spTree>
+    <p:extLst>
+      <p:ext uri="{BB962C8B-B14F-4D97-AF65-F5344CB8AC3E}">
+        <p14:creationId xmlns:p14="http://schemas.microsoft.com/office/powerpoint/2010/main" val="940359551"/>
+      </p:ext>
+    </p:extLst>
+  </p:cSld>
+  <p:clrMapOvr>
+    <a:masterClrMapping/>
+  </p:clrMapOvr>
+</p:sld>
+</file>
+
+<file path=ppt/slides/slide13.xml><?xml version="1.0" encoding="utf-8"?>
+<p:sld xmlns:a="http://schemas.openxmlformats.org/drawingml/2006/main" xmlns:r="http://schemas.openxmlformats.org/officeDocument/2006/relationships" xmlns:p="http://schemas.openxmlformats.org/presentationml/2006/main">
+  <p:cSld>
+    <p:spTree>
+      <p:nvGrpSpPr>
+        <p:cNvPr id="1" name="">
+          <a:extLst>
+            <a:ext uri="{FF2B5EF4-FFF2-40B4-BE49-F238E27FC236}">
+              <a16:creationId xmlns:a16="http://schemas.microsoft.com/office/drawing/2014/main" id="{2DE0253F-D52B-B3C7-E078-E49565D37836}"/>
+            </a:ext>
+          </a:extLst>
+        </p:cNvPr>
+        <p:cNvGrpSpPr/>
+        <p:nvPr/>
+      </p:nvGrpSpPr>
+      <p:grpSpPr>
+        <a:xfrm>
+          <a:off x="0" y="0"/>
+          <a:ext cx="0" cy="0"/>
+          <a:chOff x="0" y="0"/>
+          <a:chExt cx="0" cy="0"/>
+        </a:xfrm>
+      </p:grpSpPr>
       <p:pic>
         <p:nvPicPr>
-          <p:cNvPr id="9" name="Picture 8">
+          <p:cNvPr id="7" name="Picture 6">
             <a:extLst>
               <a:ext uri="{FF2B5EF4-FFF2-40B4-BE49-F238E27FC236}">
-                <a16:creationId xmlns:a16="http://schemas.microsoft.com/office/drawing/2014/main" id="{6D0CCBB0-A7B1-70E5-55D9-DD98F6B4CF93}"/>
+                <a16:creationId xmlns:a16="http://schemas.microsoft.com/office/drawing/2014/main" id="{47B69E89-4066-7EC3-CFE4-1E1705C14E14}"/>
               </a:ext>
             </a:extLst>
           </p:cNvPr>
@@ -6820,27 +6906,63 @@
           <p:nvPr/>
         </p:nvPicPr>
         <p:blipFill>
-          <a:blip r:embed="rId3"/>
+          <a:blip r:embed="rId2"/>
           <a:stretch>
             <a:fillRect/>
           </a:stretch>
         </p:blipFill>
         <p:spPr>
           <a:xfrm>
-            <a:off x="4742839" y="1472867"/>
-            <a:ext cx="3707829" cy="2335094"/>
+            <a:off x="0" y="546886"/>
+            <a:ext cx="9144000" cy="5764228"/>
           </a:xfrm>
           <a:prstGeom prst="rect">
             <a:avLst/>
           </a:prstGeom>
         </p:spPr>
       </p:pic>
+    </p:spTree>
+    <p:extLst>
+      <p:ext uri="{BB962C8B-B14F-4D97-AF65-F5344CB8AC3E}">
+        <p14:creationId xmlns:p14="http://schemas.microsoft.com/office/powerpoint/2010/main" val="3357544633"/>
+      </p:ext>
+    </p:extLst>
+  </p:cSld>
+  <p:clrMapOvr>
+    <a:masterClrMapping/>
+  </p:clrMapOvr>
+</p:sld>
+</file>
+
+<file path=ppt/slides/slide14.xml><?xml version="1.0" encoding="utf-8"?>
+<p:sld xmlns:a="http://schemas.openxmlformats.org/drawingml/2006/main" xmlns:r="http://schemas.openxmlformats.org/officeDocument/2006/relationships" xmlns:p="http://schemas.openxmlformats.org/presentationml/2006/main">
+  <p:cSld>
+    <p:spTree>
+      <p:nvGrpSpPr>
+        <p:cNvPr id="1" name="">
+          <a:extLst>
+            <a:ext uri="{FF2B5EF4-FFF2-40B4-BE49-F238E27FC236}">
+              <a16:creationId xmlns:a16="http://schemas.microsoft.com/office/drawing/2014/main" id="{01A48424-53D3-A542-82B3-425FEEBCB088}"/>
+            </a:ext>
+          </a:extLst>
+        </p:cNvPr>
+        <p:cNvGrpSpPr/>
+        <p:nvPr/>
+      </p:nvGrpSpPr>
+      <p:grpSpPr>
+        <a:xfrm>
+          <a:off x="0" y="0"/>
+          <a:ext cx="0" cy="0"/>
+          <a:chOff x="0" y="0"/>
+          <a:chExt cx="0" cy="0"/>
+        </a:xfrm>
+      </p:grpSpPr>
       <p:pic>
         <p:nvPicPr>
-          <p:cNvPr id="11" name="Picture 10">
+          <p:cNvPr id="7" name="Picture 6">
             <a:extLst>
               <a:ext uri="{FF2B5EF4-FFF2-40B4-BE49-F238E27FC236}">
-                <a16:creationId xmlns:a16="http://schemas.microsoft.com/office/drawing/2014/main" id="{C799A9F0-A831-5F5E-0141-0CF759189F43}"/>
+                <a16:creationId xmlns:a16="http://schemas.microsoft.com/office/drawing/2014/main" id="{20C332C2-21A4-2BF1-28A7-C00008970CF5}"/>
               </a:ext>
             </a:extLst>
           </p:cNvPr>
@@ -6850,15 +6972,15 @@
           <p:nvPr/>
         </p:nvPicPr>
         <p:blipFill>
-          <a:blip r:embed="rId4"/>
+          <a:blip r:embed="rId2"/>
           <a:stretch>
             <a:fillRect/>
           </a:stretch>
         </p:blipFill>
         <p:spPr>
           <a:xfrm>
-            <a:off x="2555068" y="4048758"/>
-            <a:ext cx="3789852" cy="2399945"/>
+            <a:off x="0" y="532921"/>
+            <a:ext cx="9144000" cy="5792157"/>
           </a:xfrm>
           <a:prstGeom prst="rect">
             <a:avLst/>
@@ -6866,6 +6988,11 @@
         </p:spPr>
       </p:pic>
     </p:spTree>
+    <p:extLst>
+      <p:ext uri="{BB962C8B-B14F-4D97-AF65-F5344CB8AC3E}">
+        <p14:creationId xmlns:p14="http://schemas.microsoft.com/office/powerpoint/2010/main" val="909603061"/>
+      </p:ext>
+    </p:extLst>
   </p:cSld>
   <p:clrMapOvr>
     <a:masterClrMapping/>
@@ -6873,7 +7000,7 @@
 </p:sld>
 </file>
 
-<file path=ppt/slides/slide12.xml><?xml version="1.0" encoding="utf-8"?>
+<file path=ppt/slides/slide15.xml><?xml version="1.0" encoding="utf-8"?>
 <p:sld xmlns:a="http://schemas.openxmlformats.org/drawingml/2006/main" xmlns:r="http://schemas.openxmlformats.org/officeDocument/2006/relationships" xmlns:p="http://schemas.openxmlformats.org/presentationml/2006/main">
   <p:cSld>
     <p:spTree>
@@ -6961,6 +7088,7 @@
           <a:bodyPr/>
           <a:lstStyle/>
           <a:p>
+            <a:pPr algn="l"/>
             <a:r>
               <a:rPr dirty="0">
                 <a:solidFill>
@@ -7052,6 +7180,7 @@
           <a:bodyPr/>
           <a:lstStyle/>
           <a:p>
+            <a:pPr algn="l"/>
             <a:r>
               <a:rPr dirty="0">
                 <a:solidFill>
@@ -7238,6 +7367,7 @@
           <a:bodyPr/>
           <a:lstStyle/>
           <a:p>
+            <a:pPr algn="l"/>
             <a:r>
               <a:rPr dirty="0">
                 <a:solidFill>
@@ -7323,6 +7453,7 @@
           <a:bodyPr/>
           <a:lstStyle/>
           <a:p>
+            <a:pPr algn="l"/>
             <a:r>
               <a:rPr dirty="0">
                 <a:solidFill>
@@ -7391,14 +7522,6 @@
 <file path=ppt/slides/slide6.xml><?xml version="1.0" encoding="utf-8"?>
 <p:sld xmlns:a="http://schemas.openxmlformats.org/drawingml/2006/main" xmlns:r="http://schemas.openxmlformats.org/officeDocument/2006/relationships" xmlns:p="http://schemas.openxmlformats.org/presentationml/2006/main">
   <p:cSld>
-    <p:bg>
-      <p:bgPr>
-        <a:solidFill>
-          <a:schemeClr val="bg1"/>
-        </a:solidFill>
-        <a:effectLst/>
-      </p:bgPr>
-    </p:bg>
     <p:spTree>
       <p:nvGrpSpPr>
         <p:cNvPr id="1" name=""/>
@@ -7425,7 +7548,7 @@
         </p:nvSpPr>
         <p:spPr>
           <a:xfrm>
-            <a:off x="677726" y="350520"/>
+            <a:off x="544647" y="314620"/>
             <a:ext cx="7765322" cy="970450"/>
           </a:xfrm>
         </p:spPr>
@@ -7433,6 +7556,7 @@
           <a:bodyPr/>
           <a:lstStyle/>
           <a:p>
+            <a:pPr algn="l"/>
             <a:r>
               <a:rPr dirty="0">
                 <a:solidFill>
@@ -8157,6 +8281,7 @@
           <a:bodyPr/>
           <a:lstStyle/>
           <a:p>
+            <a:pPr algn="l"/>
             <a:r>
               <a:rPr dirty="0">
                 <a:solidFill>
@@ -8813,6 +8938,7 @@
           <a:bodyPr/>
           <a:lstStyle/>
           <a:p>
+            <a:pPr algn="l"/>
             <a:r>
               <a:rPr dirty="0">
                 <a:solidFill>
@@ -8969,6 +9095,7 @@
           <a:bodyPr/>
           <a:lstStyle/>
           <a:p>
+            <a:pPr algn="l"/>
             <a:r>
               <a:rPr dirty="0">
                 <a:solidFill>
@@ -9016,11 +9143,19 @@
           </a:p>
           <a:p>
             <a:r>
-              <a:rPr dirty="0"/>
+              <a:rPr dirty="0">
+                <a:solidFill>
+                  <a:srgbClr val="00B0F0"/>
+                </a:solidFill>
+              </a:rPr>
               <a:t>Rating vs sales</a:t>
             </a:r>
             <a:r>
-              <a:rPr lang="en-US" dirty="0"/>
+              <a:rPr lang="en-US" dirty="0">
+                <a:solidFill>
+                  <a:srgbClr val="00B0F0"/>
+                </a:solidFill>
+              </a:rPr>
               <a:t>: </a:t>
             </a:r>
           </a:p>
@@ -9031,13 +9166,6 @@
             <a:r>
               <a:rPr lang="en-US" dirty="0"/>
               <a:t>Average Seller rating is 4.08</a:t>
-            </a:r>
-            <a:endParaRPr dirty="0"/>
-          </a:p>
-          <a:p>
-            <a:r>
-              <a:rPr dirty="0"/>
-              <a:t>Insights</a:t>
             </a:r>
           </a:p>
         </p:txBody>

</xml_diff>